<commit_message>
fix: grup numarasi 12 olarak duzeltildi (kapak + README + API + metadata); rapor/sunum PDF dosyalari repoya eklendi
</commit_message>
<xml_diff>
--- a/sunum/Guvenli_Surus_Sunum.pptx
+++ b/sunum/Guvenli_Surus_Sunum.pptx
@@ -2086,7 +2086,7 @@
         <p:spPr>
           <a:xfrm>
             <a:off x="731520" y="4983480"/>
-            <a:ext cx="4572000" cy="274320"/>
+            <a:ext cx="7315200" cy="274320"/>
           </a:xfrm>
           <a:prstGeom prst="rect">
             <a:avLst/>
@@ -2110,7 +2110,7 @@
                 <a:ea typeface="Trebuchet MS" pitchFamily="34" charset="-122"/>
                 <a:cs typeface="Trebuchet MS" pitchFamily="34" charset="-120"/>
               </a:rPr>
-              <a:t>PROJE EKİBİ</a:t>
+              <a:t>GRUP 12  ·  PROJE EKİBİ</a:t>
             </a:r>
             <a:endParaRPr lang="en-US" sz="1100" dirty="0"/>
           </a:p>

</xml_diff>